<commit_message>
Update slides, made the speaker notes into bullet points to be more readable, and fixed slide metadata
</commit_message>
<xml_diff>
--- a/slides/WireGuard-udp2raw-detection.pptx
+++ b/slides/WireGuard-udp2raw-detection.pptx
@@ -510,59 +510,54 @@
           <a:lstStyle/>
           <a:p>
             <a:r>
-              <a:t>Hi, I'm Steven, this is Nicholas. We spent the semester building and</a:t>
-            </a:r>
-          </a:p>
-          <a:p>
-            <a:r>
-              <a:t>breaking a WireGuard deployment.</a:t>
+              <a:t>Setup</a:t>
+            </a:r>
+          </a:p>
+          <a:p>
+            <a:r>
+              <a:t>  • WireGuard = modern VPN. Encrypts well, but doesn't try to hide that it IS a VPN.</a:t>
+            </a:r>
+          </a:p>
+          <a:p>
+            <a:r>
+              <a:t>  • Hiding the VPN is explicitly out of scope per Donenfeld's 2017 paper.</a:t>
+            </a:r>
+          </a:p>
+          <a:p>
+            <a:r>
+              <a:t>  • Question: does the most popular hiding tool actually hide it?</a:t>
             </a:r>
           </a:p>
           <a:p/>
           <a:p>
             <a:r>
-              <a:t>WireGuard is a modern VPN. It encrypts your traffic well, but it doesn't</a:t>
-            </a:r>
-          </a:p>
-          <a:p>
-            <a:r>
-              <a:t>try to hide that you're running a VPN — that's an explicit design choice</a:t>
-            </a:r>
-          </a:p>
-          <a:p>
-            <a:r>
-              <a:t>by its author. The question we're asking is whether the most popular</a:t>
-            </a:r>
-          </a:p>
-          <a:p>
-            <a:r>
-              <a:t>tool people use to hide WireGuard actually hides it. The tool is called</a:t>
-            </a:r>
-          </a:p>
-          <a:p>
-            <a:r>
-              <a:t>udp2raw. About 260,000 downloads, used in Iran and China, zero</a:t>
-            </a:r>
-          </a:p>
-          <a:p>
-            <a:r>
-              <a:t>peer-reviewed analysis until this paper.</a:t>
+              <a:t>The tool: udp2raw</a:t>
+            </a:r>
+          </a:p>
+          <a:p>
+            <a:r>
+              <a:t>  • Used in Iran and China for censorship circumvention.</a:t>
+            </a:r>
+          </a:p>
+          <a:p>
+            <a:r>
+              <a:t>  • Zero peer-reviewed analysis before this paper.</a:t>
             </a:r>
           </a:p>
           <a:p/>
           <a:p>
             <a:r>
-              <a:t>Two results. An active attack: send five test packets, identify a</a:t>
-            </a:r>
-          </a:p>
-          <a:p>
-            <a:r>
-              <a:t>udp2raw server in 8.5 seconds. A passive attack: watch traffic, measure</a:t>
-            </a:r>
-          </a:p>
-          <a:p>
-            <a:r>
-              <a:t>two things about it, classifier hits 99.9% accuracy.</a:t>
+              <a:t>Two results we'll show</a:t>
+            </a:r>
+          </a:p>
+          <a:p>
+            <a:r>
+              <a:t>  • Active attack: 5 test packets, identifies udp2raw server in 8.5 s.</a:t>
+            </a:r>
+          </a:p>
+          <a:p>
+            <a:r>
+              <a:t>  • Passive attack: 2 traffic features, classifier at 99.9% accuracy.</a:t>
             </a:r>
           </a:p>
         </p:txBody>
@@ -632,68 +627,63 @@
           <a:lstStyle/>
           <a:p>
             <a:r>
-              <a:t>Every WireGuard packet starts with the same four bytes — a type byte</a:t>
-            </a:r>
-          </a:p>
-          <a:p>
-            <a:r>
-              <a:t>that's always 1, 2, 3, or 4, followed by three zero bytes. The</a:t>
-            </a:r>
-          </a:p>
-          <a:p>
-            <a:r>
-              <a:t>handshake packets are also fixed sizes: 148, 92, and 64 bytes. So you</a:t>
-            </a:r>
-          </a:p>
-          <a:p>
-            <a:r>
-              <a:t>can identify WireGuard without decrypting anything, just by looking at</a:t>
-            </a:r>
-          </a:p>
-          <a:p>
-            <a:r>
-              <a:t>the first four bytes and the length. Twenty-five lines of Python is the</a:t>
-            </a:r>
-          </a:p>
-          <a:p>
-            <a:r>
-              <a:t>whole detector. The Wu et al. paper at USENIX Security 2023 confirms</a:t>
-            </a:r>
-          </a:p>
-          <a:p>
-            <a:r>
-              <a:t>the Great Firewall does exactly this.</a:t>
+              <a:t>Why WireGuard is easy to spot</a:t>
+            </a:r>
+          </a:p>
+          <a:p>
+            <a:r>
+              <a:t>  • First byte = message type, always 1, 2, 3, or 4.</a:t>
+            </a:r>
+          </a:p>
+          <a:p>
+            <a:r>
+              <a:t>  • Next 3 bytes = always zero.</a:t>
+            </a:r>
+          </a:p>
+          <a:p>
+            <a:r>
+              <a:t>  • Handshake packets = fixed sizes: 148, 92, 64 bytes.</a:t>
+            </a:r>
+          </a:p>
+          <a:p>
+            <a:r>
+              <a:t>  • → Identify WireGuard from first 4 bytes + packet length. No decryption needed.</a:t>
+            </a:r>
+          </a:p>
+          <a:p>
+            <a:r>
+              <a:t>  • 25-line Python detector is the whole thing.</a:t>
+            </a:r>
+          </a:p>
+          <a:p>
+            <a:r>
+              <a:t>  • Wu et al., USENIX Security 2023: Great Firewall does exactly this.</a:t>
             </a:r>
           </a:p>
           <a:p/>
           <a:p>
             <a:r>
-              <a:t>Important caveat: this is not a WireGuard vulnerability. Donenfeld's</a:t>
-            </a:r>
-          </a:p>
-          <a:p>
-            <a:r>
-              <a:t>original 2017 paper explicitly says hiding the VPN's existence is out</a:t>
-            </a:r>
-          </a:p>
-          <a:p>
-            <a:r>
-              <a:t>of scope — that's a job for a separate tool. The question isn't "can</a:t>
-            </a:r>
-          </a:p>
-          <a:p>
-            <a:r>
-              <a:t>you detect WireGuard," it's "can you detect it once it's wrapped in</a:t>
-            </a:r>
-          </a:p>
-          <a:p>
-            <a:r>
-              <a:t>the most popular hiding tool." That tool is udp2raw, which is the</a:t>
-            </a:r>
-          </a:p>
-          <a:p>
-            <a:r>
-              <a:t>next slide.</a:t>
+              <a:t>Important caveat — not a vulnerability</a:t>
+            </a:r>
+          </a:p>
+          <a:p>
+            <a:r>
+              <a:t>  • Donenfeld's 2017 paper says hiding the VPN's existence is out of scope.</a:t>
+            </a:r>
+          </a:p>
+          <a:p>
+            <a:r>
+              <a:t>  • That's a job for a separate tool on top.</a:t>
+            </a:r>
+          </a:p>
+          <a:p>
+            <a:r>
+              <a:t>  • Real question: can you detect WireGuard once it's wrapped in the popular hiding tool?</a:t>
+            </a:r>
+          </a:p>
+          <a:p>
+            <a:r>
+              <a:t>  • → That tool is udp2raw. Next slide.</a:t>
             </a:r>
           </a:p>
         </p:txBody>
@@ -763,74 +753,64 @@
           <a:lstStyle/>
           <a:p>
             <a:r>
-              <a:t>Two paths through our lab, same WireGuard keys both ways, only the</a:t>
-            </a:r>
-          </a:p>
-          <a:p>
-            <a:r>
-              <a:t>outer transport differs. Direct path: WireGuard packets ride UDP</a:t>
-            </a:r>
-          </a:p>
-          <a:p>
-            <a:r>
-              <a:t>directly — the path the Great Firewall already detects. Obfuscated</a:t>
-            </a:r>
-          </a:p>
-          <a:p>
-            <a:r>
-              <a:t>path: udp2raw rewraps each WireGuard packet to look like a TCP segment</a:t>
-            </a:r>
-          </a:p>
-          <a:p>
-            <a:r>
-              <a:t>on port 4096. udp2raw calls this "faketcp" — it's not a real TCP</a:t>
-            </a:r>
-          </a:p>
-          <a:p>
-            <a:r>
-              <a:t>connection underneath, just shaped like one. TCP looks normal because</a:t>
-            </a:r>
-          </a:p>
-          <a:p>
-            <a:r>
-              <a:t>it's what web browsers use.</a:t>
+              <a:t>Two paths in our lab (same WG keys, only the outer transport differs)</a:t>
+            </a:r>
+          </a:p>
+          <a:p>
+            <a:r>
+              <a:t>  • Direct: WireGuard over UDP. What the Great Firewall already blocks.</a:t>
+            </a:r>
+          </a:p>
+          <a:p>
+            <a:r>
+              <a:t>  • Obfuscated: udp2raw rewraps each WG packet as a TCP segment on port 4096.</a:t>
+            </a:r>
+          </a:p>
+          <a:p>
+            <a:r>
+              <a:t>  • "faketcp" = shaped like TCP but not a real TCP connection.</a:t>
+            </a:r>
+          </a:p>
+          <a:p>
+            <a:r>
+              <a:t>  • Why TCP? Looks normal — it's what web browsers use.</a:t>
             </a:r>
           </a:p>
           <a:p/>
           <a:p>
             <a:r>
-              <a:t>Why udp2raw specifically. Roughly 259,000 binary downloads — actual</a:t>
-            </a:r>
-          </a:p>
-          <a:p>
-            <a:r>
-              <a:t>runs, not GitHub stars. Reportedly blocked at the ISP level in Iran</a:t>
-            </a:r>
-          </a:p>
-          <a:p>
-            <a:r>
-              <a:t>(udp2raw issue #505, net4people thread #253). And zero peer-reviewed</a:t>
-            </a:r>
-          </a:p>
-          <a:p>
-            <a:r>
-              <a:t>analysis: we searched USENIX, NDSS, IMC, FOCI, PETS, CCS. Nothing.</a:t>
+              <a:t>Why udp2raw specifically</a:t>
+            </a:r>
+          </a:p>
+          <a:p>
+            <a:r>
+              <a:t>  • ~259,000 binary downloads (actual runs, not GitHub stars).</a:t>
+            </a:r>
+          </a:p>
+          <a:p>
+            <a:r>
+              <a:t>  • Reportedly blocked at ISP level in Iran (issue #505, net4people #253).</a:t>
+            </a:r>
+          </a:p>
+          <a:p>
+            <a:r>
+              <a:t>  • Zero peer-reviewed analysis. Searched USENIX, NDSS, IMC, FOCI, PETS, CCS.</a:t>
             </a:r>
           </a:p>
           <a:p/>
           <a:p>
             <a:r>
-              <a:t>Other tools like AmneziaWG and swgp-go modify WireGuard itself — that's</a:t>
-            </a:r>
-          </a:p>
-          <a:p>
-            <a:r>
-              <a:t>a different category. udp2raw is the only big, unstudied tool in the</a:t>
-            </a:r>
-          </a:p>
-          <a:p>
-            <a:r>
-              <a:t>"wrap it generically" category, so that's our target.</a:t>
+              <a:t>Why not other tools?</a:t>
+            </a:r>
+          </a:p>
+          <a:p>
+            <a:r>
+              <a:t>  • AmneziaWG, swgp-go = modify WireGuard itself. Different category.</a:t>
+            </a:r>
+          </a:p>
+          <a:p>
+            <a:r>
+              <a:t>  • udp2raw = only big, unstudied tool in the "wrap it generically" category.</a:t>
             </a:r>
           </a:p>
         </p:txBody>
@@ -900,90 +880,90 @@
           <a:lstStyle/>
           <a:p>
             <a:r>
-              <a:t>Two attacks. "Active" means we send packets and watch the reply;</a:t>
-            </a:r>
-          </a:p>
-          <a:p>
-            <a:r>
-              <a:t>"passive" means we just watch traffic going by. We didn't invent this</a:t>
-            </a:r>
-          </a:p>
-          <a:p>
-            <a:r>
-              <a:t>pattern — the Xue et al. Distinguished Paper at USENIX Security 2022</a:t>
-            </a:r>
-          </a:p>
-          <a:p>
-            <a:r>
-              <a:t>did it for OpenVPN. We apply the same template to WireGuard-in-udp2raw,</a:t>
-            </a:r>
-          </a:p>
-          <a:p>
-            <a:r>
-              <a:t>which they didn't cover.</a:t>
+              <a:t>Two attacks, definitions</a:t>
+            </a:r>
+          </a:p>
+          <a:p>
+            <a:r>
+              <a:t>  • Active = send packets, watch the reply.</a:t>
+            </a:r>
+          </a:p>
+          <a:p>
+            <a:r>
+              <a:t>  • Passive = just watch traffic going by.</a:t>
+            </a:r>
+          </a:p>
+          <a:p>
+            <a:r>
+              <a:t>  • Template from Xue et al., USENIX Security 2022 Distinguished Paper (did OpenVPN, not WireGuard).</a:t>
             </a:r>
           </a:p>
           <a:p/>
           <a:p>
             <a:r>
-              <a:t>Left card, C1, active: five TCP probes, under nine seconds, same answer</a:t>
-            </a:r>
-          </a:p>
-          <a:p>
-            <a:r>
-              <a:t>every time. Walking through the actual probes on the next slide.</a:t>
+              <a:t>C1 — Active (left card)</a:t>
+            </a:r>
+          </a:p>
+          <a:p>
+            <a:r>
+              <a:t>  • 5 TCP probes, under 9 seconds.</a:t>
+            </a:r>
+          </a:p>
+          <a:p>
+            <a:r>
+              <a:t>  • Same answer every time. Details next slide.</a:t>
             </a:r>
           </a:p>
           <a:p/>
           <a:p>
             <a:r>
-              <a:t>Right card, C2, passive: for each traffic flow — meaning one</a:t>
-            </a:r>
-          </a:p>
-          <a:p>
-            <a:r>
-              <a:t>conversation between two computers — we compute two numbers and feed</a:t>
-            </a:r>
-          </a:p>
-          <a:p>
-            <a:r>
-              <a:t>them to a Random Forest, which is a standard machine-learning model</a:t>
-            </a:r>
-          </a:p>
-          <a:p>
-            <a:r>
-              <a:t>that learns rules from examples. The two numbers come from how the</a:t>
-            </a:r>
-          </a:p>
-          <a:p>
-            <a:r>
-              <a:t>protocols are written: WireGuard pads every packet to the maximum size,</a:t>
-            </a:r>
-          </a:p>
-          <a:p>
-            <a:r>
-              <a:t>and udp2raw acknowledges every wrapped packet one-for-one. Those are</a:t>
-            </a:r>
-          </a:p>
-          <a:p>
-            <a:r>
-              <a:t>mechanical, not statistical.</a:t>
+              <a:t>C2 — Passive (right card)</a:t>
+            </a:r>
+          </a:p>
+          <a:p>
+            <a:r>
+              <a:t>  • Flow = one conversation between two computers.</a:t>
+            </a:r>
+          </a:p>
+          <a:p>
+            <a:r>
+              <a:t>  • For each flow, compute 2 numbers, feed to a Random Forest.</a:t>
+            </a:r>
+          </a:p>
+          <a:p>
+            <a:r>
+              <a:t>  • Random Forest (RF) = standard ML model that learns rules from examples.</a:t>
+            </a:r>
+          </a:p>
+          <a:p>
+            <a:r>
+              <a:t>  • Features are mechanical, not statistical:</a:t>
+            </a:r>
+          </a:p>
+          <a:p>
+            <a:r>
+              <a:t>      – WireGuard pads every packet to max size.</a:t>
+            </a:r>
+          </a:p>
+          <a:p>
+            <a:r>
+              <a:t>      – udp2raw acks every wrapped packet 1:1.</a:t>
             </a:r>
           </a:p>
           <a:p/>
           <a:p>
             <a:r>
-              <a:t>Trained on 24 WireGuard flows we captured ourselves, plus 1058 normal</a:t>
-            </a:r>
-          </a:p>
-          <a:p>
-            <a:r>
-              <a:t>flows from ISCXVPN2016 — the standard public dataset for this kind of</a:t>
-            </a:r>
-          </a:p>
-          <a:p>
-            <a:r>
-              <a:t>work.</a:t>
+              <a:t>Training data</a:t>
+            </a:r>
+          </a:p>
+          <a:p>
+            <a:r>
+              <a:t>  • 24 WireGuard flows we captured ourselves.</a:t>
+            </a:r>
+          </a:p>
+          <a:p>
+            <a:r>
+              <a:t>  • 1058 normal flows from ISCXVPN2016 (standard public dataset for this work).</a:t>
             </a:r>
           </a:p>
         </p:txBody>
@@ -1053,80 +1033,122 @@
           <a:lstStyle/>
           <a:p>
             <a:r>
-              <a:t>Three columns, same server, three ports. Port 22 is real SSH — our</a:t>
-            </a:r>
-          </a:p>
-          <a:p>
-            <a:r>
-              <a:t>real-TCP control. Port 4096 is udp2raw. Port 9999 is closed — negative</a:t>
-            </a:r>
-          </a:p>
-          <a:p>
-            <a:r>
-              <a:t>control. TCP terms in the table: SYN starts a connection, SYN-ACK</a:t>
-            </a:r>
-          </a:p>
-          <a:p>
-            <a:r>
-              <a:t>accepts it, RST rejects, FIN closes.</a:t>
+              <a:t>Setup — three columns, same server, three ports</a:t>
+            </a:r>
+          </a:p>
+          <a:p>
+            <a:r>
+              <a:t>  • TCP/22 = real SSH (real-TCP control).</a:t>
+            </a:r>
+          </a:p>
+          <a:p>
+            <a:r>
+              <a:t>  • TCP/4096 = udp2raw.</a:t>
+            </a:r>
+          </a:p>
+          <a:p>
+            <a:r>
+              <a:t>  • TCP/9999 = closed (negative control).</a:t>
             </a:r>
           </a:p>
           <a:p/>
           <a:p>
             <a:r>
-              <a:t>The two orange "silent" probes don't help: udp2raw answers SYN</a:t>
-            </a:r>
-          </a:p>
-          <a:p>
-            <a:r>
-              <a:t>because that's the disguise, and the kernel — not udp2raw — generates</a:t>
-            </a:r>
-          </a:p>
-          <a:p>
-            <a:r>
-              <a:t>the RST on the bogus ACK.</a:t>
+              <a:t>TCP terms for the table</a:t>
+            </a:r>
+          </a:p>
+          <a:p>
+            <a:r>
+              <a:t>  • SYN starts a connection. SYN-ACK accepts. RST rejects. FIN closes.</a:t>
             </a:r>
           </a:p>
           <a:p/>
           <a:p>
             <a:r>
-              <a:t>The signal is the other three. Probe 2 is a SYN with 32 bytes of</a:t>
-            </a:r>
-          </a:p>
-          <a:p>
-            <a:r>
-              <a:t>payload. Probe 4 is a SYN with an unusual TCP option. Probe 5 is a FIN</a:t>
-            </a:r>
-          </a:p>
-          <a:p>
-            <a:r>
-              <a:t>to a port with no connection. A real Linux kernel answers all three.</a:t>
-            </a:r>
-          </a:p>
-          <a:p>
-            <a:r>
-              <a:t>udp2raw drops all three because its parser was written for one specific</a:t>
-            </a:r>
-          </a:p>
-          <a:p>
-            <a:r>
-              <a:t>TCP shape. Count silent responses: real TCP scores 0, udp2raw scores 3.</a:t>
+              <a:t>Probes that DON'T discriminate (answered by both)</a:t>
+            </a:r>
+          </a:p>
+          <a:p>
+            <a:r>
+              <a:t>  • P1 (SYN): udp2raw answers — that's the disguise.</a:t>
+            </a:r>
+          </a:p>
+          <a:p>
+            <a:r>
+              <a:t>  • P3 (bogus ACK): kernel (not udp2raw) generates the RST.</a:t>
             </a:r>
           </a:p>
           <a:p/>
           <a:p>
             <a:r>
-              <a:t>Timing: half a second for real TCP, 8.5 seconds for udp2raw (we wait</a:t>
-            </a:r>
-          </a:p>
-          <a:p>
-            <a:r>
-              <a:t>out timeouts on the silent probes), 15.5 for the closed port. Same</a:t>
-            </a:r>
-          </a:p>
-          <a:p>
-            <a:r>
-              <a:t>verdict 5 out of 5 trials.</a:t>
+              <a:t>The signal — probes 2, 4, 5</a:t>
+            </a:r>
+          </a:p>
+          <a:p>
+            <a:r>
+              <a:t>  • P2: SYN with 32 bytes of payload.</a:t>
+            </a:r>
+          </a:p>
+          <a:p>
+            <a:r>
+              <a:t>  • P4: SYN with unusual TCP option.</a:t>
+            </a:r>
+          </a:p>
+          <a:p>
+            <a:r>
+              <a:t>  • P5: FIN to a port with no connection.</a:t>
+            </a:r>
+          </a:p>
+          <a:p>
+            <a:r>
+              <a:t>  • Real Linux kernel answers all three. udp2raw drops all three.</a:t>
+            </a:r>
+          </a:p>
+          <a:p>
+            <a:r>
+              <a:t>  • udp2raw's parser was written for one TCP shape; anything else, it ignores.</a:t>
+            </a:r>
+          </a:p>
+          <a:p/>
+          <a:p>
+            <a:r>
+              <a:t>Rule</a:t>
+            </a:r>
+          </a:p>
+          <a:p>
+            <a:r>
+              <a:t>  • Count silent responses among {P2, P4, P5}.</a:t>
+            </a:r>
+          </a:p>
+          <a:p>
+            <a:r>
+              <a:t>  • Real TCP = 0 silent. udp2raw = 3 silent.</a:t>
+            </a:r>
+          </a:p>
+          <a:p/>
+          <a:p>
+            <a:r>
+              <a:t>Timing</a:t>
+            </a:r>
+          </a:p>
+          <a:p>
+            <a:r>
+              <a:t>  • Real TCP: 0.5 s.</a:t>
+            </a:r>
+          </a:p>
+          <a:p>
+            <a:r>
+              <a:t>  • udp2raw: 8.5 s (we wait out timeouts on the silent probes).</a:t>
+            </a:r>
+          </a:p>
+          <a:p>
+            <a:r>
+              <a:t>  • Closed port: 15.5 s.</a:t>
+            </a:r>
+          </a:p>
+          <a:p>
+            <a:r>
+              <a:t>  • Same verdict 5/5 trials.</a:t>
             </a:r>
           </a:p>
         </p:txBody>
@@ -1196,130 +1218,120 @@
           <a:lstStyle/>
           <a:p>
             <a:r>
-              <a:t>Two features. First: bulk_fraction is the share of packets in a flow</a:t>
-            </a:r>
-          </a:p>
-          <a:p>
-            <a:r>
-              <a:t>that are big — 1200 bytes or more. The reason it works: WireGuard pads</a:t>
-            </a:r>
-          </a:p>
-          <a:p>
-            <a:r>
-              <a:t>every packet up to near the MTU, the maximum packet size on the link,</a:t>
-            </a:r>
-          </a:p>
-          <a:p>
-            <a:r>
-              <a:t>about 1500 bytes. Web browsers don't. WireGuard flows are 55% big</a:t>
-            </a:r>
-          </a:p>
-          <a:p>
-            <a:r>
-              <a:t>packets; normal traffic is 2%. The "Cohen's d" column is a standard</a:t>
-            </a:r>
-          </a:p>
-          <a:p>
-            <a:r>
-              <a:t>measure of how cleanly two groups separate; anything over 0.8 is "large,"</a:t>
-            </a:r>
-          </a:p>
-          <a:p>
-            <a:r>
-              <a:t>and we get 3.83.</a:t>
+              <a:t>Feature 1 — bulk_fraction</a:t>
+            </a:r>
+          </a:p>
+          <a:p>
+            <a:r>
+              <a:t>  • Share of packets in a flow that are "big" (≥1200 bytes).</a:t>
+            </a:r>
+          </a:p>
+          <a:p>
+            <a:r>
+              <a:t>  • Why it works: WireGuard pads every packet up to near MTU (~1500 B).</a:t>
+            </a:r>
+          </a:p>
+          <a:p>
+            <a:r>
+              <a:t>  • MTU (or Maximum Transmission Unit)= max packet size the link will carry.</a:t>
+            </a:r>
+          </a:p>
+          <a:p>
+            <a:r>
+              <a:t>  • WireGuard: 55% big packets. Normal: 2%.</a:t>
+            </a:r>
+          </a:p>
+          <a:p>
+            <a:r>
+              <a:t>  • Cohen's d = 3.83.</a:t>
+            </a:r>
+          </a:p>
+          <a:p>
+            <a:r>
+              <a:t>  • Cohen's d = "A measurement that quantifies the difference between two averages in units of standard deviation" Or, how cleanly two groups separate. Over 0.8 is "large." We have 3.83.</a:t>
             </a:r>
           </a:p>
           <a:p/>
           <a:p>
             <a:r>
-              <a:t>Second feature: ack60_fraction, the share of 60-byte TCP ACK packets.</a:t>
-            </a:r>
-          </a:p>
-          <a:p>
-            <a:r>
-              <a:t>Normal TCP uses "delayed ACK" — one acknowledgment per two data</a:t>
-            </a:r>
-          </a:p>
-          <a:p>
-            <a:r>
-              <a:t>packets, so about 33% ACKs. udp2raw breaks this. It wraps each</a:t>
-            </a:r>
-          </a:p>
-          <a:p>
-            <a:r>
-              <a:t>WireGuard packet as one separate TCP segment, the kernel ACKs each</a:t>
-            </a:r>
-          </a:p>
-          <a:p>
-            <a:r>
-              <a:t>arrival individually, and the ACK fraction climbs. We measure 30% for</a:t>
-            </a:r>
-          </a:p>
-          <a:p>
-            <a:r>
-              <a:t>WireGuard-in-udp2raw vs. 7% for normal traffic. Cohen's d of 1.27 —</a:t>
-            </a:r>
-          </a:p>
-          <a:p>
-            <a:r>
-              <a:t>still a large effect.</a:t>
+              <a:t>Feature 2 — ack60_fraction</a:t>
+            </a:r>
+          </a:p>
+          <a:p>
+            <a:r>
+              <a:t>  • Share of 60-byte TCP ACK packets.</a:t>
+            </a:r>
+          </a:p>
+          <a:p>
+            <a:r>
+              <a:t>  • Normal TCP uses "delayed ACK" — 1 ACK per 2 data packets, so ~33% ACKs.</a:t>
+            </a:r>
+          </a:p>
+          <a:p>
+            <a:r>
+              <a:t>  • udp2raw breaks this: each WG packet wrapped as 1 separate TCP segment.</a:t>
+            </a:r>
+          </a:p>
+          <a:p>
+            <a:r>
+              <a:t>  • Kernel ACKs each arrival individually → ACK fraction climbs.</a:t>
+            </a:r>
+          </a:p>
+          <a:p>
+            <a:r>
+              <a:t>  • WG-in-udp2raw: 30%. Normal: 7%. Cohen's d = 1.27 (still large).</a:t>
             </a:r>
           </a:p>
           <a:p/>
           <a:p>
             <a:r>
-              <a:t>Scatter on the right: 1082 flows total. Orange is WireGuard, grey is</a:t>
-            </a:r>
-          </a:p>
-          <a:p>
-            <a:r>
-              <a:t>normal traffic. They barely overlap. All 24 WireGuard flows have</a:t>
-            </a:r>
-          </a:p>
-          <a:p>
-            <a:r>
-              <a:t>bulk_fraction at least 0.32. Only 4 of 1058 normal flows fall anywhere</a:t>
-            </a:r>
-          </a:p>
-          <a:p>
-            <a:r>
-              <a:t>near the WireGuard cluster.</a:t>
+              <a:t>Scatter plot (right)</a:t>
+            </a:r>
+          </a:p>
+          <a:p>
+            <a:r>
+              <a:t>  • 1082 flows total. Orange = WireGuard. Grey = normal.</a:t>
+            </a:r>
+          </a:p>
+          <a:p>
+            <a:r>
+              <a:t>  • Barely overlap.</a:t>
+            </a:r>
+          </a:p>
+          <a:p>
+            <a:r>
+              <a:t>  • All 24 WG flows have bulk_fraction ≥ 0.32.</a:t>
+            </a:r>
+          </a:p>
+          <a:p>
+            <a:r>
+              <a:t>  • Only 4 of 1058 normal flows are anywhere near the WG cluster.</a:t>
             </a:r>
           </a:p>
           <a:p/>
           <a:p>
             <a:r>
-              <a:t>Orange note bottom-left, brief story on scientific honesty. Going in, I</a:t>
-            </a:r>
-          </a:p>
-          <a:p>
-            <a:r>
-              <a:t>expected dominant_size_fraction — how concentrated the most common</a:t>
-            </a:r>
-          </a:p>
-          <a:p>
-            <a:r>
-              <a:t>packet size is — to be the killer feature. The real data inverted that:</a:t>
-            </a:r>
-          </a:p>
-          <a:p>
-            <a:r>
-              <a:t>the public dataset has lots of idle keepalive flows where every packet</a:t>
-            </a:r>
-          </a:p>
-          <a:p>
-            <a:r>
-              <a:t>is identical, so they score higher than WireGuard does. We dropped that</a:t>
-            </a:r>
-          </a:p>
-          <a:p>
-            <a:r>
-              <a:t>feature. The two that survived are the ones grounded in protocol</a:t>
-            </a:r>
-          </a:p>
-          <a:p>
-            <a:r>
-              <a:t>mechanics, not intuition.</a:t>
+              <a:t>Orange note (bottom-left) — scientific honesty</a:t>
+            </a:r>
+          </a:p>
+          <a:p>
+            <a:r>
+              <a:t>  • I expected dominant_size_fraction to be the killer feature.</a:t>
+            </a:r>
+          </a:p>
+          <a:p>
+            <a:r>
+              <a:t>  • Real data inverted it: public dataset has idle keepalive flows where every packet is identical.</a:t>
+            </a:r>
+          </a:p>
+          <a:p>
+            <a:r>
+              <a:t>  • Those flows score HIGHER than WireGuard on that feature.</a:t>
+            </a:r>
+          </a:p>
+          <a:p>
+            <a:r>
+              <a:t>  • We dropped it. Surviving features are grounded in protocol mechanics, not intuition.</a:t>
             </a:r>
           </a:p>
         </p:txBody>
@@ -1389,105 +1401,69 @@
           <a:lstStyle/>
           <a:p>
             <a:r>
-              <a:t>Headline numbers, with definitions since some of these terms aren't</a:t>
-            </a:r>
-          </a:p>
-          <a:p>
-            <a:r>
-              <a:t>universal.</a:t>
+              <a:t>Headline numbers (with definitions)</a:t>
+            </a:r>
+          </a:p>
+          <a:p>
+            <a:r>
+              <a:t>  • Accuracy 99.91% — overall fraction labeled correctly.</a:t>
+            </a:r>
+          </a:p>
+          <a:p>
+            <a:r>
+              <a:t>  • Precision 1.000 — when we say "WireGuard," we're always right. Zero false alarms on 1058 normal flows.</a:t>
+            </a:r>
+          </a:p>
+          <a:p>
+            <a:r>
+              <a:t>  • Recall 0.958 — we catch 23 of 24 actual WG flows. One slips through.</a:t>
+            </a:r>
+          </a:p>
+          <a:p>
+            <a:r>
+              <a:t>  • ROC AUC 1.000 — single score from 0.5 (random) to 1.0 (perfect), across all sensitivity settings. We're at the ceiling.</a:t>
             </a:r>
           </a:p>
           <a:p/>
           <a:p>
             <a:r>
-              <a:t>Accuracy 99.91% — overall fraction labeled correctly.</a:t>
-            </a:r>
-          </a:p>
-          <a:p>
-            <a:r>
-              <a:t>Precision 1.000 — when we say "WireGuard," we're always right. Zero</a:t>
-            </a:r>
-          </a:p>
-          <a:p>
-            <a:r>
-              <a:t>false alarms on 1058 normal flows.</a:t>
-            </a:r>
-          </a:p>
-          <a:p>
-            <a:r>
-              <a:t>Recall 0.958 — we catch 23 of the 24 actual WireGuard flows. One slips</a:t>
-            </a:r>
-          </a:p>
-          <a:p>
-            <a:r>
-              <a:t>through.</a:t>
-            </a:r>
-          </a:p>
-          <a:p>
-            <a:r>
-              <a:t>ROC AUC 1.000 — a single number from 0.5 (random) to 1.0 (perfect)</a:t>
-            </a:r>
-          </a:p>
-          <a:p>
-            <a:r>
-              <a:t>that scores the classifier across all sensitivity settings. We're at</a:t>
-            </a:r>
-          </a:p>
-          <a:p>
-            <a:r>
-              <a:t>the ceiling.</a:t>
+              <a:t>Adding more features doesn't help (small table)</a:t>
+            </a:r>
+          </a:p>
+          <a:p>
+            <a:r>
+              <a:t>  • RF 8 features catches 1 FEWER WG flow than RF 2 features.</a:t>
+            </a:r>
+          </a:p>
+          <a:p>
+            <a:r>
+              <a:t>  • Extra features added noise, not signal.</a:t>
+            </a:r>
+          </a:p>
+          <a:p>
+            <a:r>
+              <a:t>  • LR = Logistic Regression, simpler model that draws a straight line between classes.</a:t>
+            </a:r>
+          </a:p>
+          <a:p>
+            <a:r>
+              <a:t>  • LR catches everything but raises ~3% false alarms — real boundary isn't straight.</a:t>
             </a:r>
           </a:p>
           <a:p/>
           <a:p>
             <a:r>
-              <a:t>Small table below: adding more features doesn't help. The 8-feature</a:t>
-            </a:r>
-          </a:p>
-          <a:p>
-            <a:r>
-              <a:t>Random Forest catches one fewer WireGuard flow than the 2-feature</a:t>
-            </a:r>
-          </a:p>
-          <a:p>
-            <a:r>
-              <a:t>version — extra features added noise, not signal. Logistic regression</a:t>
-            </a:r>
-          </a:p>
-          <a:p>
-            <a:r>
-              <a:t>(LR), which is a simpler model that draws a straight line between the</a:t>
-            </a:r>
-          </a:p>
-          <a:p>
-            <a:r>
-              <a:t>classes, catches everything but pays with 3% false alarms because the</a:t>
-            </a:r>
-          </a:p>
-          <a:p>
-            <a:r>
-              <a:t>real boundary isn't straight.</a:t>
-            </a:r>
-          </a:p>
-          <a:p/>
-          <a:p>
-            <a:r>
-              <a:t>Right side. Confusion matrix on top — that's the 2x2 grid of correct</a:t>
-            </a:r>
-          </a:p>
-          <a:p>
-            <a:r>
-              <a:t>and incorrect labels. Almost everything sits on the diagonal. ROC curve</a:t>
-            </a:r>
-          </a:p>
-          <a:p>
-            <a:r>
-              <a:t>on the bottom hugs the top-left corner, which is the shape of a</a:t>
-            </a:r>
-          </a:p>
-          <a:p>
-            <a:r>
-              <a:t>near-perfect classifier.</a:t>
+              <a:t>Plots on the right</a:t>
+            </a:r>
+          </a:p>
+          <a:p>
+            <a:r>
+              <a:t>  • Top = confusion matrix: 2x2 grid of correct vs incorrect labels. Almost everything on the diagonal.</a:t>
+            </a:r>
+          </a:p>
+          <a:p>
+            <a:r>
+              <a:t>  • Bottom = ROC curve hugs the top-left corner. Shape of a near-perfect classifier.</a:t>
             </a:r>
           </a:p>
         </p:txBody>
@@ -1557,78 +1533,68 @@
           <a:lstStyle/>
           <a:p>
             <a:r>
-              <a:t>Lit positioning so the audience knows we read. The Xue group at</a:t>
-            </a:r>
-          </a:p>
-          <a:p>
-            <a:r>
-              <a:t>Michigan has the dominant line. Their 2022 OpenVPN paper is our</a:t>
-            </a:r>
-          </a:p>
-          <a:p>
-            <a:r>
-              <a:t>methodology template. Their 2024 paper detects nested TLS handshakes —</a:t>
-            </a:r>
-          </a:p>
-          <a:p>
-            <a:r>
-              <a:t>doesn't fire on WireGuard because WireGuard doesn't use TLS. Their 2025</a:t>
-            </a:r>
-          </a:p>
-          <a:p>
-            <a:r>
-              <a:t>NDSS paper uses cross-layer round-trip-time anomalies — attenuates on</a:t>
-            </a:r>
-          </a:p>
-          <a:p>
-            <a:r>
-              <a:t>short UDP flows like ours. So those protocol-agnostic methods don't</a:t>
-            </a:r>
-          </a:p>
-          <a:p>
-            <a:r>
-              <a:t>already solve the WireGuard-in-udp2raw case. Protocol-specific</a:t>
-            </a:r>
-          </a:p>
-          <a:p>
-            <a:r>
-              <a:t>structural features remain the available approach.</a:t>
+              <a:t>Lit positioning — Xue group at Michigan dominates this space</a:t>
+            </a:r>
+          </a:p>
+          <a:p>
+            <a:r>
+              <a:t>  • 2022 OpenVPN paper → our methodology template.</a:t>
+            </a:r>
+          </a:p>
+          <a:p>
+            <a:r>
+              <a:t>  • 2024 paper detects nested TLS handshakes → doesn't fire (WG has no TLS).</a:t>
+            </a:r>
+          </a:p>
+          <a:p>
+            <a:r>
+              <a:t>  • 2025 NDSS uses cross-layer RTT anomalies → attenuates on our short UDP flows.</a:t>
+            </a:r>
+          </a:p>
+          <a:p>
+            <a:r>
+              <a:t>  • → Protocol-agnostic methods don't solve our case. Protocol-specific structural features remain the approach.</a:t>
             </a:r>
           </a:p>
           <a:p/>
           <a:p>
             <a:r>
-              <a:t>Right side, what we are NOT claiming. Single client and server, no</a:t>
-            </a:r>
-          </a:p>
-          <a:p>
-            <a:r>
-              <a:t>ISP-scale data. One version of udp2raw — later forks may differ. Both</a:t>
-            </a:r>
-          </a:p>
-          <a:p>
-            <a:r>
-              <a:t>attacks are defeatable by a maintainer who patches the tool — delayed</a:t>
-            </a:r>
-          </a:p>
-          <a:p>
-            <a:r>
-              <a:t>ACK plus a smaller WireGuard MTU weakens C2. The bogus-ACK probe is</a:t>
-            </a:r>
-          </a:p>
-          <a:p>
-            <a:r>
-              <a:t>mildly hostile, so an adversary would fire it only at already-suspected</a:t>
-            </a:r>
-          </a:p>
-          <a:p>
-            <a:r>
-              <a:t>hosts. And we didn't compare against AmneziaWG, swgp-go, or wstunnel —</a:t>
-            </a:r>
-          </a:p>
-          <a:p>
-            <a:r>
-              <a:t>future work.</a:t>
+              <a:t>What we are NOT claiming</a:t>
+            </a:r>
+          </a:p>
+          <a:p>
+            <a:r>
+              <a:t>  • Single client/server. No ISP-scale data.</a:t>
+            </a:r>
+          </a:p>
+          <a:p>
+            <a:r>
+              <a:t>  • One version of udp2raw (v20230206.0). Later forks may differ.</a:t>
+            </a:r>
+          </a:p>
+          <a:p>
+            <a:r>
+              <a:t>  • Defeatable by a maintainer:</a:t>
+            </a:r>
+          </a:p>
+          <a:p>
+            <a:r>
+              <a:t>      – Delayed ACK + smaller WG MTU weakens C2.</a:t>
+            </a:r>
+          </a:p>
+          <a:p>
+            <a:r>
+              <a:t>      – More conformant TCP emulation weakens C1.</a:t>
+            </a:r>
+          </a:p>
+          <a:p>
+            <a:r>
+              <a:t>  • Bogus-ACK probe (P3) is mildly hostile → fire only at already-suspected hosts.</a:t>
+            </a:r>
+          </a:p>
+          <a:p>
+            <a:r>
+              <a:t>  • Not benchmarked against AmneziaWG, a more popular obfuscator for WG, or swgp-go, wstunnel. Future work.</a:t>
             </a:r>
           </a:p>
         </p:txBody>
@@ -1698,77 +1664,90 @@
           <a:lstStyle/>
           <a:p>
             <a:r>
-              <a:t>Four takeaways.</a:t>
+              <a:t>1. WireGuard's wire format leaks</a:t>
+            </a:r>
+          </a:p>
+          <a:p>
+            <a:r>
+              <a:t>  • Known result. Re-implemented as our baseline.</a:t>
             </a:r>
           </a:p>
           <a:p/>
           <a:p>
             <a:r>
-              <a:t>One. WireGuard's wire format leaks. Known result; we re-implement it as</a:t>
-            </a:r>
-          </a:p>
-          <a:p>
-            <a:r>
-              <a:t>our baseline.</a:t>
+              <a:t>2. udp2raw doesn't fix it</a:t>
+            </a:r>
+          </a:p>
+          <a:p>
+            <a:r>
+              <a:t>  • 8.5 s with the 5-packet prober (C1).</a:t>
+            </a:r>
+          </a:p>
+          <a:p>
+            <a:r>
+              <a:t>  • 2 passive features, AUC = 1.0 (C2).</a:t>
+            </a:r>
+          </a:p>
+          <a:p>
+            <a:r>
+              <a:t>  • Pick your weapon.</a:t>
             </a:r>
           </a:p>
           <a:p/>
           <a:p>
             <a:r>
-              <a:t>Two. udp2raw doesn't actually fix it. 8.5 seconds with the five-packet</a:t>
-            </a:r>
-          </a:p>
-          <a:p>
-            <a:r>
-              <a:t>prober, or two passive features at AUC 1.0. Pick your weapon.</a:t>
+              <a:t>3. Not a statistical fluke — mechanical</a:t>
+            </a:r>
+          </a:p>
+          <a:p>
+            <a:r>
+              <a:t>  • WG pads to MTU because that's its design.</a:t>
+            </a:r>
+          </a:p>
+          <a:p>
+            <a:r>
+              <a:t>  • udp2raw acks 1:1 because that's how it wraps.</a:t>
+            </a:r>
+          </a:p>
+          <a:p>
+            <a:r>
+              <a:t>  • udp2raw drops unfamiliar TCP shapes — parser was written for one shape.</a:t>
+            </a:r>
+          </a:p>
+          <a:p>
+            <a:r>
+              <a:t>  • This is because udp2raw fakes TCP in userspace with a minimal parser to only handle the packet shapes it needs, everything else gets dropped.</a:t>
+            </a:r>
+          </a:p>
+          <a:p>
+            <a:r>
+              <a:t>           </a:t>
+            </a:r>
+          </a:p>
+          <a:p>
+            <a:r>
+              <a:t>4. Defenses are obvious</a:t>
+            </a:r>
+          </a:p>
+          <a:p>
+            <a:r>
+              <a:t>  • Delayed ACK + smaller WG MTU kills C2.</a:t>
+            </a:r>
+          </a:p>
+          <a:p>
+            <a:r>
+              <a:t>  • More conformant TCP emulation kills C1.</a:t>
+            </a:r>
+          </a:p>
+          <a:p>
+            <a:r>
+              <a:t>  • Sketched in the paper, not patched upstream. Somebody else's PR.</a:t>
             </a:r>
           </a:p>
           <a:p/>
           <a:p>
             <a:r>
-              <a:t>Three. Not a statistical fluke. WireGuard pads to MTU because that's</a:t>
-            </a:r>
-          </a:p>
-          <a:p>
-            <a:r>
-              <a:t>its design. udp2raw acks 1:1 because that's how it wraps. udp2raw drops</a:t>
-            </a:r>
-          </a:p>
-          <a:p>
-            <a:r>
-              <a:t>unfamiliar TCP shapes because its parser was written for one shape.</a:t>
-            </a:r>
-          </a:p>
-          <a:p>
-            <a:r>
-              <a:t>Mechanical consequences, not accidents.</a:t>
-            </a:r>
-          </a:p>
-          <a:p/>
-          <a:p>
-            <a:r>
-              <a:t>Four. Defenses are obvious. Delayed ACK plus a smaller WireGuard MTU</a:t>
-            </a:r>
-          </a:p>
-          <a:p>
-            <a:r>
-              <a:t>kills C2. More conformant TCP emulation kills C1. We sketch both in the</a:t>
-            </a:r>
-          </a:p>
-          <a:p>
-            <a:r>
-              <a:t>paper but didn't patch the upstream tool. Somebody else's pull request</a:t>
-            </a:r>
-          </a:p>
-          <a:p>
-            <a:r>
-              <a:t>to write.</a:t>
-            </a:r>
-          </a:p>
-          <a:p/>
-          <a:p>
-            <a:r>
-              <a:t>Happy to take questions. Live demo ready if there's interest.</a:t>
+              <a:t>Happy to take questions. LIVE DEMO NEXT.</a:t>
             </a:r>
           </a:p>
         </p:txBody>
@@ -11783,7 +11762,7 @@
                 </a:solidFill>
                 <a:latin typeface="Calibri"/>
               </a:rPr>
-              <a:t>•   Not benchmarked against AmneziaWG, swgp-go, wstunnel. Future work.</a:t>
+              <a:t>•   Not benchmarked against AmneziaWG, a more popular obfuscator for WG, or swgp-go, wstunnel. Future work.</a:t>
             </a:r>
           </a:p>
         </p:txBody>

</xml_diff>